<commit_message>
R1-T08: Objectives and progress tracking — connects daily activity to quarterly/annual role objectives (manual/count-linked/sum-linked-value progress, overachievement never hidden, at-risk + recovery workflow, objective review export)
</commit_message>
<xml_diff>
--- a/reports/Orbit2_Deck_Atlassian_2026-Q3.pptx
+++ b/reports/Orbit2_Deck_Atlassian_2026-Q3.pptx
@@ -582,7 +582,7 @@
               <c:numCache>
                 <c:ptCount val="3"/>
                 <c:pt idx="0">
-                  <c:v>2</c:v>
+                  <c:v>15</c:v>
                 </c:pt>
                 <c:pt idx="1">
                   <c:v>0</c:v>
@@ -1974,7 +1974,7 @@
                 <a:ea typeface="Calibri" pitchFamily="34" charset="-122"/>
                 <a:cs typeface="Calibri" pitchFamily="34" charset="-120"/>
               </a:rPr>
-              <a:t>Generated 2026-07-16</a:t>
+              <a:t>Generated 2026-07-18</a:t>
             </a:r>
             <a:endParaRPr lang="en-US" sz="1300" dirty="0"/>
           </a:p>
@@ -4379,7 +4379,7 @@
                 <a:ea typeface="Calibri" pitchFamily="34" charset="-122"/>
                 <a:cs typeface="Calibri" pitchFamily="34" charset="-120"/>
               </a:rPr>
-              <a:t>2 mention(s) found by the automated 12h web scan</a:t>
+              <a:t>15 mention(s) found by the automated 12h web scan</a:t>
             </a:r>
             <a:endParaRPr lang="en-US" sz="1300" dirty="0"/>
           </a:p>
@@ -4457,7 +4457,7 @@
                 <a:ea typeface="Calibri" pitchFamily="34" charset="-122"/>
                 <a:cs typeface="Calibri" pitchFamily="34" charset="-120"/>
               </a:rPr>
-              <a:t>Communardo scales as an Atlassian &amp; Microsoft platform across Europe</a:t>
+              <a:t>Communardo Products rebrands as Elevatic unifying Marketplace app portfolio</a:t>
             </a:r>
             <a:endParaRPr lang="en-US" sz="1100" dirty="0"/>
           </a:p>
@@ -4535,7 +4535,319 @@
                 <a:ea typeface="Calibri" pitchFamily="34" charset="-122"/>
                 <a:cs typeface="Calibri" pitchFamily="34" charset="-120"/>
               </a:rPr>
-              <a:t>Communardo strengthens European presence with expansion into the Benelux region</a:t>
+              <a:t>Anje Hickey appointed CEO for Atlassian Professional Services in Europe</a:t>
+            </a:r>
+            <a:endParaRPr lang="en-US" sz="1100" dirty="0"/>
+          </a:p>
+        </p:txBody>
+      </p:sp>
+      <p:sp>
+        <p:nvSpPr>
+          <p:cNvPr id="9" name="Text 6"/>
+          <p:cNvSpPr/>
+          <p:nvPr/>
+        </p:nvSpPr>
+        <p:spPr>
+          <a:xfrm>
+            <a:off x="5029200" y="2971800"/>
+            <a:ext cx="1005840" cy="274320"/>
+          </a:xfrm>
+          <a:prstGeom prst="rect">
+            <a:avLst/>
+          </a:prstGeom>
+          <a:noFill/>
+          <a:ln/>
+        </p:spPr>
+        <p:txBody>
+          <a:bodyPr wrap="square" rtlCol="0" anchor="ctr"/>
+          <a:lstStyle/>
+          <a:p>
+            <a:pPr indent="0" marL="0">
+              <a:buNone/>
+            </a:pPr>
+            <a:r>
+              <a:rPr lang="en-US" sz="900" b="1" dirty="0">
+                <a:solidFill>
+                  <a:srgbClr val="059669"/>
+                </a:solidFill>
+                <a:latin typeface="Calibri" pitchFamily="34" charset="0"/>
+                <a:ea typeface="Calibri" pitchFamily="34" charset="-122"/>
+                <a:cs typeface="Calibri" pitchFamily="34" charset="-120"/>
+              </a:rPr>
+              <a:t>POSITIVE</a:t>
+            </a:r>
+            <a:endParaRPr lang="en-US" sz="900" dirty="0"/>
+          </a:p>
+        </p:txBody>
+      </p:sp>
+      <p:sp>
+        <p:nvSpPr>
+          <p:cNvPr id="10" name="Text 7"/>
+          <p:cNvSpPr/>
+          <p:nvPr/>
+        </p:nvSpPr>
+        <p:spPr>
+          <a:xfrm>
+            <a:off x="6126480" y="2971800"/>
+            <a:ext cx="5486400" cy="594360"/>
+          </a:xfrm>
+          <a:prstGeom prst="rect">
+            <a:avLst/>
+          </a:prstGeom>
+          <a:noFill/>
+          <a:ln/>
+        </p:spPr>
+        <p:txBody>
+          <a:bodyPr wrap="square" rtlCol="0" anchor="t"/>
+          <a:lstStyle/>
+          <a:p>
+            <a:pPr indent="0" marL="0">
+              <a:buNone/>
+            </a:pPr>
+            <a:r>
+              <a:rPr lang="en-US" sz="1100" dirty="0">
+                <a:solidFill>
+                  <a:srgbClr val="1E293B"/>
+                </a:solidFill>
+                <a:latin typeface="Calibri" pitchFamily="34" charset="0"/>
+                <a:ea typeface="Calibri" pitchFamily="34" charset="-122"/>
+                <a:cs typeface="Calibri" pitchFamily="34" charset="-120"/>
+              </a:rPr>
+              <a:t>Communardo partners with Bregal Unternehmerkapital to drive growth strategy and European expansion</a:t>
+            </a:r>
+            <a:endParaRPr lang="en-US" sz="1100" dirty="0"/>
+          </a:p>
+        </p:txBody>
+      </p:sp>
+      <p:sp>
+        <p:nvSpPr>
+          <p:cNvPr id="11" name="Text 8"/>
+          <p:cNvSpPr/>
+          <p:nvPr/>
+        </p:nvSpPr>
+        <p:spPr>
+          <a:xfrm>
+            <a:off x="5029200" y="3657600"/>
+            <a:ext cx="1005840" cy="274320"/>
+          </a:xfrm>
+          <a:prstGeom prst="rect">
+            <a:avLst/>
+          </a:prstGeom>
+          <a:noFill/>
+          <a:ln/>
+        </p:spPr>
+        <p:txBody>
+          <a:bodyPr wrap="square" rtlCol="0" anchor="ctr"/>
+          <a:lstStyle/>
+          <a:p>
+            <a:pPr indent="0" marL="0">
+              <a:buNone/>
+            </a:pPr>
+            <a:r>
+              <a:rPr lang="en-US" sz="900" b="1" dirty="0">
+                <a:solidFill>
+                  <a:srgbClr val="059669"/>
+                </a:solidFill>
+                <a:latin typeface="Calibri" pitchFamily="34" charset="0"/>
+                <a:ea typeface="Calibri" pitchFamily="34" charset="-122"/>
+                <a:cs typeface="Calibri" pitchFamily="34" charset="-120"/>
+              </a:rPr>
+              <a:t>POSITIVE</a:t>
+            </a:r>
+            <a:endParaRPr lang="en-US" sz="900" dirty="0"/>
+          </a:p>
+        </p:txBody>
+      </p:sp>
+      <p:sp>
+        <p:nvSpPr>
+          <p:cNvPr id="12" name="Text 9"/>
+          <p:cNvSpPr/>
+          <p:nvPr/>
+        </p:nvSpPr>
+        <p:spPr>
+          <a:xfrm>
+            <a:off x="6126480" y="3657600"/>
+            <a:ext cx="5486400" cy="594360"/>
+          </a:xfrm>
+          <a:prstGeom prst="rect">
+            <a:avLst/>
+          </a:prstGeom>
+          <a:noFill/>
+          <a:ln/>
+        </p:spPr>
+        <p:txBody>
+          <a:bodyPr wrap="square" rtlCol="0" anchor="t"/>
+          <a:lstStyle/>
+          <a:p>
+            <a:pPr indent="0" marL="0">
+              <a:buNone/>
+            </a:pPr>
+            <a:r>
+              <a:rPr lang="en-US" sz="1100" dirty="0">
+                <a:solidFill>
+                  <a:srgbClr val="1E293B"/>
+                </a:solidFill>
+                <a:latin typeface="Calibri" pitchFamily="34" charset="0"/>
+                <a:ea typeface="Calibri" pitchFamily="34" charset="-122"/>
+                <a:cs typeface="Calibri" pitchFamily="34" charset="-120"/>
+              </a:rPr>
+              <a:t>Communardo expands Industry Advisory Board with Seidensticker and Kranebitter</a:t>
+            </a:r>
+            <a:endParaRPr lang="en-US" sz="1100" dirty="0"/>
+          </a:p>
+        </p:txBody>
+      </p:sp>
+      <p:sp>
+        <p:nvSpPr>
+          <p:cNvPr id="13" name="Text 10"/>
+          <p:cNvSpPr/>
+          <p:nvPr/>
+        </p:nvSpPr>
+        <p:spPr>
+          <a:xfrm>
+            <a:off x="5029200" y="4343400"/>
+            <a:ext cx="1005840" cy="274320"/>
+          </a:xfrm>
+          <a:prstGeom prst="rect">
+            <a:avLst/>
+          </a:prstGeom>
+          <a:noFill/>
+          <a:ln/>
+        </p:spPr>
+        <p:txBody>
+          <a:bodyPr wrap="square" rtlCol="0" anchor="ctr"/>
+          <a:lstStyle/>
+          <a:p>
+            <a:pPr indent="0" marL="0">
+              <a:buNone/>
+            </a:pPr>
+            <a:r>
+              <a:rPr lang="en-US" sz="900" b="1" dirty="0">
+                <a:solidFill>
+                  <a:srgbClr val="059669"/>
+                </a:solidFill>
+                <a:latin typeface="Calibri" pitchFamily="34" charset="0"/>
+                <a:ea typeface="Calibri" pitchFamily="34" charset="-122"/>
+                <a:cs typeface="Calibri" pitchFamily="34" charset="-120"/>
+              </a:rPr>
+              <a:t>POSITIVE</a:t>
+            </a:r>
+            <a:endParaRPr lang="en-US" sz="900" dirty="0"/>
+          </a:p>
+        </p:txBody>
+      </p:sp>
+      <p:sp>
+        <p:nvSpPr>
+          <p:cNvPr id="14" name="Text 11"/>
+          <p:cNvSpPr/>
+          <p:nvPr/>
+        </p:nvSpPr>
+        <p:spPr>
+          <a:xfrm>
+            <a:off x="6126480" y="4343400"/>
+            <a:ext cx="5486400" cy="594360"/>
+          </a:xfrm>
+          <a:prstGeom prst="rect">
+            <a:avLst/>
+          </a:prstGeom>
+          <a:noFill/>
+          <a:ln/>
+        </p:spPr>
+        <p:txBody>
+          <a:bodyPr wrap="square" rtlCol="0" anchor="t"/>
+          <a:lstStyle/>
+          <a:p>
+            <a:pPr indent="0" marL="0">
+              <a:buNone/>
+            </a:pPr>
+            <a:r>
+              <a:rPr lang="en-US" sz="1100" dirty="0">
+                <a:solidFill>
+                  <a:srgbClr val="1E293B"/>
+                </a:solidFill>
+                <a:latin typeface="Calibri" pitchFamily="34" charset="0"/>
+                <a:ea typeface="Calibri" pitchFamily="34" charset="-122"/>
+                <a:cs typeface="Calibri" pitchFamily="34" charset="-120"/>
+              </a:rPr>
+              <a:t>Communardo enters Nordic market with acquisition of Stretch Addera in Sweden</a:t>
+            </a:r>
+            <a:endParaRPr lang="en-US" sz="1100" dirty="0"/>
+          </a:p>
+        </p:txBody>
+      </p:sp>
+      <p:sp>
+        <p:nvSpPr>
+          <p:cNvPr id="15" name="Text 12"/>
+          <p:cNvSpPr/>
+          <p:nvPr/>
+        </p:nvSpPr>
+        <p:spPr>
+          <a:xfrm>
+            <a:off x="5029200" y="5029200"/>
+            <a:ext cx="1005840" cy="274320"/>
+          </a:xfrm>
+          <a:prstGeom prst="rect">
+            <a:avLst/>
+          </a:prstGeom>
+          <a:noFill/>
+          <a:ln/>
+        </p:spPr>
+        <p:txBody>
+          <a:bodyPr wrap="square" rtlCol="0" anchor="ctr"/>
+          <a:lstStyle/>
+          <a:p>
+            <a:pPr indent="0" marL="0">
+              <a:buNone/>
+            </a:pPr>
+            <a:r>
+              <a:rPr lang="en-US" sz="900" b="1" dirty="0">
+                <a:solidFill>
+                  <a:srgbClr val="059669"/>
+                </a:solidFill>
+                <a:latin typeface="Calibri" pitchFamily="34" charset="0"/>
+                <a:ea typeface="Calibri" pitchFamily="34" charset="-122"/>
+                <a:cs typeface="Calibri" pitchFamily="34" charset="-120"/>
+              </a:rPr>
+              <a:t>POSITIVE</a:t>
+            </a:r>
+            <a:endParaRPr lang="en-US" sz="900" dirty="0"/>
+          </a:p>
+        </p:txBody>
+      </p:sp>
+      <p:sp>
+        <p:nvSpPr>
+          <p:cNvPr id="16" name="Text 13"/>
+          <p:cNvSpPr/>
+          <p:nvPr/>
+        </p:nvSpPr>
+        <p:spPr>
+          <a:xfrm>
+            <a:off x="6126480" y="5029200"/>
+            <a:ext cx="5486400" cy="594360"/>
+          </a:xfrm>
+          <a:prstGeom prst="rect">
+            <a:avLst/>
+          </a:prstGeom>
+          <a:noFill/>
+          <a:ln/>
+        </p:spPr>
+        <p:txBody>
+          <a:bodyPr wrap="square" rtlCol="0" anchor="t"/>
+          <a:lstStyle/>
+          <a:p>
+            <a:pPr indent="0" marL="0">
+              <a:buNone/>
+            </a:pPr>
+            <a:r>
+              <a:rPr lang="en-US" sz="1100" dirty="0">
+                <a:solidFill>
+                  <a:srgbClr val="1E293B"/>
+                </a:solidFill>
+                <a:latin typeface="Calibri" pitchFamily="34" charset="0"/>
+                <a:ea typeface="Calibri" pitchFamily="34" charset="-122"/>
+                <a:cs typeface="Calibri" pitchFamily="34" charset="-120"/>
+              </a:rPr>
+              <a:t>Partnership with Mibex strengthens software portfolio</a:t>
             </a:r>
             <a:endParaRPr lang="en-US" sz="1100" dirty="0"/>
           </a:p>

</xml_diff>

<commit_message>
Switch financial currency from EUR to USD (app_config.json, config.py default, 6 revenue sub-metrics amended, report generator fallbacks)
</commit_message>
<xml_diff>
--- a/reports/Orbit2_Deck_Atlassian_2026-Q3.pptx
+++ b/reports/Orbit2_Deck_Atlassian_2026-Q3.pptx
@@ -582,7 +582,7 @@
               <c:numCache>
                 <c:ptCount val="3"/>
                 <c:pt idx="0">
-                  <c:v>15</c:v>
+                  <c:v>28</c:v>
                 </c:pt>
                 <c:pt idx="1">
                   <c:v>0</c:v>
@@ -4379,7 +4379,7 @@
                 <a:ea typeface="Calibri" pitchFamily="34" charset="-122"/>
                 <a:cs typeface="Calibri" pitchFamily="34" charset="-120"/>
               </a:rPr>
-              <a:t>15 mention(s) found by the automated 12h web scan</a:t>
+              <a:t>28 mention(s) found by the automated 12h web scan</a:t>
             </a:r>
             <a:endParaRPr lang="en-US" sz="1300" dirty="0"/>
           </a:p>
@@ -4457,7 +4457,7 @@
                 <a:ea typeface="Calibri" pitchFamily="34" charset="-122"/>
                 <a:cs typeface="Calibri" pitchFamily="34" charset="-120"/>
               </a:rPr>
-              <a:t>Communardo Products rebrands as Elevatic unifying Marketplace app portfolio</a:t>
+              <a:t>Communardo GmbH - Atlassian Solutions Partner Directory listing</a:t>
             </a:r>
             <a:endParaRPr lang="en-US" sz="1100" dirty="0"/>
           </a:p>
@@ -4535,7 +4535,7 @@
                 <a:ea typeface="Calibri" pitchFamily="34" charset="-122"/>
                 <a:cs typeface="Calibri" pitchFamily="34" charset="-120"/>
               </a:rPr>
-              <a:t>Anje Hickey appointed CEO for Atlassian Professional Services in Europe</a:t>
+              <a:t>Stretch Addera joins Communardo Group</a:t>
             </a:r>
             <a:endParaRPr lang="en-US" sz="1100" dirty="0"/>
           </a:p>
@@ -4613,7 +4613,7 @@
                 <a:ea typeface="Calibri" pitchFamily="34" charset="-122"/>
                 <a:cs typeface="Calibri" pitchFamily="34" charset="-120"/>
               </a:rPr>
-              <a:t>Communardo partners with Bregal Unternehmerkapital to drive growth strategy and European expansion</a:t>
+              <a:t>Expanding Nordic Coverage: Communardo Group Adds Ambientia's Atlassian Business</a:t>
             </a:r>
             <a:endParaRPr lang="en-US" sz="1100" dirty="0"/>
           </a:p>
@@ -4691,7 +4691,7 @@
                 <a:ea typeface="Calibri" pitchFamily="34" charset="-122"/>
                 <a:cs typeface="Calibri" pitchFamily="34" charset="-120"/>
               </a:rPr>
-              <a:t>Communardo expands Industry Advisory Board with Seidensticker and Kranebitter</a:t>
+              <a:t>Stretch Addera joins Communardo Group</a:t>
             </a:r>
             <a:endParaRPr lang="en-US" sz="1100" dirty="0"/>
           </a:p>
@@ -4769,7 +4769,7 @@
                 <a:ea typeface="Calibri" pitchFamily="34" charset="-122"/>
                 <a:cs typeface="Calibri" pitchFamily="34" charset="-120"/>
               </a:rPr>
-              <a:t>Communardo enters Nordic market with acquisition of Stretch Addera in Sweden</a:t>
+              <a:t>Expanding Nordic Coverage: Communardo Group Adds Ambientia's Atlassian Business</a:t>
             </a:r>
             <a:endParaRPr lang="en-US" sz="1100" dirty="0"/>
           </a:p>
@@ -4847,7 +4847,7 @@
                 <a:ea typeface="Calibri" pitchFamily="34" charset="-122"/>
                 <a:cs typeface="Calibri" pitchFamily="34" charset="-120"/>
               </a:rPr>
-              <a:t>Partnership with Mibex strengthens software portfolio</a:t>
+              <a:t>German Communardo Group, backed by Bregal Unternehmerkapital (BU), acquires Swedish Atlassian partner Stretch Addera</a:t>
             </a:r>
             <a:endParaRPr lang="en-US" sz="1100" dirty="0"/>
           </a:p>

</xml_diff>

<commit_message>
Contacts Phase 1 (R3-T01, pulled forward): identity resolution engine, contacts.csv/contact_aliases.csv/contact_evidence.jsonl registers, migration 003, validators, tests
</commit_message>
<xml_diff>
--- a/reports/Orbit2_Deck_Atlassian_2026-Q3.pptx
+++ b/reports/Orbit2_Deck_Atlassian_2026-Q3.pptx
@@ -582,10 +582,10 @@
               <c:numCache>
                 <c:ptCount val="3"/>
                 <c:pt idx="0">
-                  <c:v>28</c:v>
+                  <c:v>37</c:v>
                 </c:pt>
                 <c:pt idx="1">
-                  <c:v>0</c:v>
+                  <c:v>1</c:v>
                 </c:pt>
                 <c:pt idx="2">
                   <c:v>0</c:v>
@@ -1974,7 +1974,7 @@
                 <a:ea typeface="Calibri" pitchFamily="34" charset="-122"/>
                 <a:cs typeface="Calibri" pitchFamily="34" charset="-120"/>
               </a:rPr>
-              <a:t>Generated 2026-07-18</a:t>
+              <a:t>Generated 2026-07-21</a:t>
             </a:r>
             <a:endParaRPr lang="en-US" sz="1300" dirty="0"/>
           </a:p>
@@ -4379,7 +4379,7 @@
                 <a:ea typeface="Calibri" pitchFamily="34" charset="-122"/>
                 <a:cs typeface="Calibri" pitchFamily="34" charset="-120"/>
               </a:rPr>
-              <a:t>28 mention(s) found by the automated 12h web scan</a:t>
+              <a:t>38 mention(s) found by the automated 12h web scan</a:t>
             </a:r>
             <a:endParaRPr lang="en-US" sz="1300" dirty="0"/>
           </a:p>
@@ -4412,13 +4412,13 @@
             <a:r>
               <a:rPr lang="en-US" sz="900" b="1" dirty="0">
                 <a:solidFill>
-                  <a:srgbClr val="059669"/>
-                </a:solidFill>
-                <a:latin typeface="Calibri" pitchFamily="34" charset="0"/>
-                <a:ea typeface="Calibri" pitchFamily="34" charset="-122"/>
-                <a:cs typeface="Calibri" pitchFamily="34" charset="-120"/>
-              </a:rPr>
-              <a:t>POSITIVE</a:t>
+                  <a:srgbClr val="64748B"/>
+                </a:solidFill>
+                <a:latin typeface="Calibri" pitchFamily="34" charset="0"/>
+                <a:ea typeface="Calibri" pitchFamily="34" charset="-122"/>
+                <a:cs typeface="Calibri" pitchFamily="34" charset="-120"/>
+              </a:rPr>
+              <a:t>NEUTRAL</a:t>
             </a:r>
             <a:endParaRPr lang="en-US" sz="900" dirty="0"/>
           </a:p>
@@ -4457,7 +4457,7 @@
                 <a:ea typeface="Calibri" pitchFamily="34" charset="-122"/>
                 <a:cs typeface="Calibri" pitchFamily="34" charset="-120"/>
               </a:rPr>
-              <a:t>Communardo GmbH - Atlassian Solutions Partner Directory listing</a:t>
+              <a:t>Elevatic - Atlassian Marketplace vendor listing</a:t>
             </a:r>
             <a:endParaRPr lang="en-US" sz="1100" dirty="0"/>
           </a:p>
@@ -4535,7 +4535,7 @@
                 <a:ea typeface="Calibri" pitchFamily="34" charset="-122"/>
                 <a:cs typeface="Calibri" pitchFamily="34" charset="-120"/>
               </a:rPr>
-              <a:t>Stretch Addera joins Communardo Group</a:t>
+              <a:t>Communardo Switzerland - Atlassian Solutions Partner Directory listing</a:t>
             </a:r>
             <a:endParaRPr lang="en-US" sz="1100" dirty="0"/>
           </a:p>
@@ -4613,7 +4613,7 @@
                 <a:ea typeface="Calibri" pitchFamily="34" charset="-122"/>
                 <a:cs typeface="Calibri" pitchFamily="34" charset="-120"/>
               </a:rPr>
-              <a:t>Expanding Nordic Coverage: Communardo Group Adds Ambientia's Atlassian Business</a:t>
+              <a:t>BU-backed Communardo adds on Stretch Addera</a:t>
             </a:r>
             <a:endParaRPr lang="en-US" sz="1100" dirty="0"/>
           </a:p>
@@ -4691,7 +4691,7 @@
                 <a:ea typeface="Calibri" pitchFamily="34" charset="-122"/>
                 <a:cs typeface="Calibri" pitchFamily="34" charset="-120"/>
               </a:rPr>
-              <a:t>Stretch Addera joins Communardo Group</a:t>
+              <a:t>Communardo Acquires Stretch Addera from Stretch AB</a:t>
             </a:r>
             <a:endParaRPr lang="en-US" sz="1100" dirty="0"/>
           </a:p>
@@ -4769,7 +4769,7 @@
                 <a:ea typeface="Calibri" pitchFamily="34" charset="-122"/>
                 <a:cs typeface="Calibri" pitchFamily="34" charset="-120"/>
               </a:rPr>
-              <a:t>Expanding Nordic Coverage: Communardo Group Adds Ambientia's Atlassian Business</a:t>
+              <a:t>Paul Hastings advises BU Bregal Unternehmerkapital on acquisition of Stretch Addera by Communardo</a:t>
             </a:r>
             <a:endParaRPr lang="en-US" sz="1100" dirty="0"/>
           </a:p>
@@ -4847,7 +4847,7 @@
                 <a:ea typeface="Calibri" pitchFamily="34" charset="-122"/>
                 <a:cs typeface="Calibri" pitchFamily="34" charset="-120"/>
               </a:rPr>
-              <a:t>German Communardo Group, backed by Bregal Unternehmerkapital (BU), acquires Swedish Atlassian partner Stretch Addera</a:t>
+              <a:t>Communardo and Mibex Software join forces</a:t>
             </a:r>
             <a:endParaRPr lang="en-US" sz="1100" dirty="0"/>
           </a:p>

</xml_diff>

<commit_message>
Objective detail click-through view: My Impact tab + Cowork dashboard — full breakdown, auto-updating summary, linked evidence/activity detail, action points; evidence files viewable in dashboard only
</commit_message>
<xml_diff>
--- a/reports/Orbit2_Deck_Atlassian_2026-Q3.pptx
+++ b/reports/Orbit2_Deck_Atlassian_2026-Q3.pptx
@@ -582,7 +582,7 @@
               <c:numCache>
                 <c:ptCount val="3"/>
                 <c:pt idx="0">
-                  <c:v>37</c:v>
+                  <c:v>42</c:v>
                 </c:pt>
                 <c:pt idx="1">
                   <c:v>1</c:v>
@@ -4379,7 +4379,7 @@
                 <a:ea typeface="Calibri" pitchFamily="34" charset="-122"/>
                 <a:cs typeface="Calibri" pitchFamily="34" charset="-120"/>
               </a:rPr>
-              <a:t>38 mention(s) found by the automated 12h web scan</a:t>
+              <a:t>43 mention(s) found by the automated 12h web scan</a:t>
             </a:r>
             <a:endParaRPr lang="en-US" sz="1300" dirty="0"/>
           </a:p>
@@ -4412,13 +4412,13 @@
             <a:r>
               <a:rPr lang="en-US" sz="900" b="1" dirty="0">
                 <a:solidFill>
-                  <a:srgbClr val="64748B"/>
-                </a:solidFill>
-                <a:latin typeface="Calibri" pitchFamily="34" charset="0"/>
-                <a:ea typeface="Calibri" pitchFamily="34" charset="-122"/>
-                <a:cs typeface="Calibri" pitchFamily="34" charset="-120"/>
-              </a:rPr>
-              <a:t>NEUTRAL</a:t>
+                  <a:srgbClr val="059669"/>
+                </a:solidFill>
+                <a:latin typeface="Calibri" pitchFamily="34" charset="0"/>
+                <a:ea typeface="Calibri" pitchFamily="34" charset="-122"/>
+                <a:cs typeface="Calibri" pitchFamily="34" charset="-120"/>
+              </a:rPr>
+              <a:t>POSITIVE</a:t>
             </a:r>
             <a:endParaRPr lang="en-US" sz="900" dirty="0"/>
           </a:p>
@@ -4457,7 +4457,7 @@
                 <a:ea typeface="Calibri" pitchFamily="34" charset="-122"/>
                 <a:cs typeface="Calibri" pitchFamily="34" charset="-120"/>
               </a:rPr>
-              <a:t>Elevatic - Atlassian Marketplace vendor listing</a:t>
+              <a:t>Communardo weitet Europa-Präsenz aus</a:t>
             </a:r>
             <a:endParaRPr lang="en-US" sz="1100" dirty="0"/>
           </a:p>
@@ -4535,7 +4535,7 @@
                 <a:ea typeface="Calibri" pitchFamily="34" charset="-122"/>
                 <a:cs typeface="Calibri" pitchFamily="34" charset="-120"/>
               </a:rPr>
-              <a:t>Communardo Switzerland - Atlassian Solutions Partner Directory listing</a:t>
+              <a:t>celix wird zu Communardo Austria (brand transition FAQ)</a:t>
             </a:r>
             <a:endParaRPr lang="en-US" sz="1100" dirty="0"/>
           </a:p>
@@ -4613,7 +4613,7 @@
                 <a:ea typeface="Calibri" pitchFamily="34" charset="-122"/>
                 <a:cs typeface="Calibri" pitchFamily="34" charset="-120"/>
               </a:rPr>
-              <a:t>BU-backed Communardo adds on Stretch Addera</a:t>
+              <a:t>Communardo welcomes celix as a new partner</a:t>
             </a:r>
             <a:endParaRPr lang="en-US" sz="1100" dirty="0"/>
           </a:p>
@@ -4691,7 +4691,7 @@
                 <a:ea typeface="Calibri" pitchFamily="34" charset="-122"/>
                 <a:cs typeface="Calibri" pitchFamily="34" charset="-120"/>
               </a:rPr>
-              <a:t>Communardo Acquires Stretch Addera from Stretch AB</a:t>
+              <a:t>Paul Hastings advises Bregal on acquisition of Celix by Communardo</a:t>
             </a:r>
             <a:endParaRPr lang="en-US" sz="1100" dirty="0"/>
           </a:p>
@@ -4769,7 +4769,7 @@
                 <a:ea typeface="Calibri" pitchFamily="34" charset="-122"/>
                 <a:cs typeface="Calibri" pitchFamily="34" charset="-120"/>
               </a:rPr>
-              <a:t>Paul Hastings advises BU Bregal Unternehmerkapital on acquisition of Stretch Addera by Communardo</a:t>
+              <a:t>BU-backed Communardo buys Celix Solutions in Austria</a:t>
             </a:r>
             <a:endParaRPr lang="en-US" sz="1100" dirty="0"/>
           </a:p>
@@ -4802,13 +4802,13 @@
             <a:r>
               <a:rPr lang="en-US" sz="900" b="1" dirty="0">
                 <a:solidFill>
-                  <a:srgbClr val="059669"/>
-                </a:solidFill>
-                <a:latin typeface="Calibri" pitchFamily="34" charset="0"/>
-                <a:ea typeface="Calibri" pitchFamily="34" charset="-122"/>
-                <a:cs typeface="Calibri" pitchFamily="34" charset="-120"/>
-              </a:rPr>
-              <a:t>POSITIVE</a:t>
+                  <a:srgbClr val="64748B"/>
+                </a:solidFill>
+                <a:latin typeface="Calibri" pitchFamily="34" charset="0"/>
+                <a:ea typeface="Calibri" pitchFamily="34" charset="-122"/>
+                <a:cs typeface="Calibri" pitchFamily="34" charset="-120"/>
+              </a:rPr>
+              <a:t>NEUTRAL</a:t>
             </a:r>
             <a:endParaRPr lang="en-US" sz="900" dirty="0"/>
           </a:p>
@@ -4847,7 +4847,7 @@
                 <a:ea typeface="Calibri" pitchFamily="34" charset="-122"/>
                 <a:cs typeface="Calibri" pitchFamily="34" charset="-120"/>
               </a:rPr>
-              <a:t>Communardo and Mibex Software join forces</a:t>
+              <a:t>Elevatic - Atlassian Marketplace vendor listing</a:t>
             </a:r>
             <a:endParaRPr lang="en-US" sz="1100" dirty="0"/>
           </a:p>

</xml_diff>

<commit_message>
IR-A1/A2/C1: fix public visibility leak for Objectives/Actions (shared visibility.py); IR-B1: has_data missing-vs-zero display signal in scoring
</commit_message>
<xml_diff>
--- a/reports/Orbit2_Deck_Atlassian_2026-Q3.pptx
+++ b/reports/Orbit2_Deck_Atlassian_2026-Q3.pptx
@@ -582,10 +582,10 @@
               <c:numCache>
                 <c:ptCount val="3"/>
                 <c:pt idx="0">
-                  <c:v>42</c:v>
+                  <c:v>50</c:v>
                 </c:pt>
                 <c:pt idx="1">
-                  <c:v>1</c:v>
+                  <c:v>2</c:v>
                 </c:pt>
                 <c:pt idx="2">
                   <c:v>0</c:v>
@@ -1974,7 +1974,7 @@
                 <a:ea typeface="Calibri" pitchFamily="34" charset="-122"/>
                 <a:cs typeface="Calibri" pitchFamily="34" charset="-120"/>
               </a:rPr>
-              <a:t>Generated 2026-07-21</a:t>
+              <a:t>Generated 2026-07-22</a:t>
             </a:r>
             <a:endParaRPr lang="en-US" sz="1300" dirty="0"/>
           </a:p>
@@ -4379,7 +4379,7 @@
                 <a:ea typeface="Calibri" pitchFamily="34" charset="-122"/>
                 <a:cs typeface="Calibri" pitchFamily="34" charset="-120"/>
               </a:rPr>
-              <a:t>43 mention(s) found by the automated 12h web scan</a:t>
+              <a:t>52 mention(s) found by the automated 12h web scan</a:t>
             </a:r>
             <a:endParaRPr lang="en-US" sz="1300" dirty="0"/>
           </a:p>
@@ -4457,7 +4457,7 @@
                 <a:ea typeface="Calibri" pitchFamily="34" charset="-122"/>
                 <a:cs typeface="Calibri" pitchFamily="34" charset="-120"/>
               </a:rPr>
-              <a:t>Communardo weitet Europa-Präsenz aus</a:t>
+              <a:t>Communardo Sweden AB - Atlassian Solutions Partner Directory listing</a:t>
             </a:r>
             <a:endParaRPr lang="en-US" sz="1100" dirty="0"/>
           </a:p>
@@ -4535,7 +4535,7 @@
                 <a:ea typeface="Calibri" pitchFamily="34" charset="-122"/>
                 <a:cs typeface="Calibri" pitchFamily="34" charset="-120"/>
               </a:rPr>
-              <a:t>celix wird zu Communardo Austria (brand transition FAQ)</a:t>
+              <a:t>aety Acquired by Communardo</a:t>
             </a:r>
             <a:endParaRPr lang="en-US" sz="1100" dirty="0"/>
           </a:p>
@@ -4613,7 +4613,7 @@
                 <a:ea typeface="Calibri" pitchFamily="34" charset="-122"/>
                 <a:cs typeface="Calibri" pitchFamily="34" charset="-120"/>
               </a:rPr>
-              <a:t>Communardo welcomes celix as a new partner</a:t>
+              <a:t>BU-backed software company Communardo acquires Austrian IT firm ByteSource</a:t>
             </a:r>
             <a:endParaRPr lang="en-US" sz="1100" dirty="0"/>
           </a:p>
@@ -4691,7 +4691,7 @@
                 <a:ea typeface="Calibri" pitchFamily="34" charset="-122"/>
                 <a:cs typeface="Calibri" pitchFamily="34" charset="-120"/>
               </a:rPr>
-              <a:t>Paul Hastings advises Bregal on acquisition of Celix by Communardo</a:t>
+              <a:t>Communardo gewinnt Bregal Unternehmerkapital als Partner (PROM12 announcement)</a:t>
             </a:r>
             <a:endParaRPr lang="en-US" sz="1100" dirty="0"/>
           </a:p>
@@ -4769,7 +4769,7 @@
                 <a:ea typeface="Calibri" pitchFamily="34" charset="-122"/>
                 <a:cs typeface="Calibri" pitchFamily="34" charset="-120"/>
               </a:rPr>
-              <a:t>BU-backed Communardo buys Celix Solutions in Austria</a:t>
+              <a:t>GOF advises PROM12 on the sale of Communardo to Bregal Unternehmerkapital</a:t>
             </a:r>
             <a:endParaRPr lang="en-US" sz="1100" dirty="0"/>
           </a:p>
@@ -4847,7 +4847,7 @@
                 <a:ea typeface="Calibri" pitchFamily="34" charset="-122"/>
                 <a:cs typeface="Calibri" pitchFamily="34" charset="-120"/>
               </a:rPr>
-              <a:t>Elevatic - Atlassian Marketplace vendor listing</a:t>
+              <a:t>Case Study: Bregal Unternehmerkapital x Communardo</a:t>
             </a:r>
             <a:endParaRPr lang="en-US" sz="1100" dirty="0"/>
           </a:p>

</xml_diff>